<commit_message>
S12 rev: same-day delivery, planned second collection (Part I)
Co-Authored-By: Claude Opus 5.5 <noreply@anthropic.com>
Claude-Session: https://claude.ai/code/session_01KNBb1Wnxwbb5ErYZmjycZ9
</commit_message>
<xml_diff>
--- a/sessions/s12/slides/s12-cloud-collection.pptx
+++ b/sessions/s12/slides/s12-cloud-collection.pptx
@@ -1136,7 +1136,7 @@
           <a:p>
             <a:r>
               <a:rPr lang="en-US" dirty="0"/>
-              <a:t>Page section 8, about two hours, Kali only. Read the safety rules aloud. Walk the room at Part C (the seal after each sync) and Part F (list before head and get). If access logs are missing, students record it and collect again later into c2: never wait silently. Nothing is torn down.</a:t>
+              <a:t>Page section 8, about two hours, Kali only. S11 and S12 share Day 6, so the incident is about an hour old at Part B: expect few or no access-log files. Part I, the second collection, runs later, at least several hours after the incident and before Session 13; agree a time with each student. Read the safety rules aloud. Walk the room at Part C (the seal after each sync) and Part F (list before head and get). Missing access logs are recorded with the time, never waited for silently. Nothing is torn down.</a:t>
             </a:r>
             <a:endParaRPr lang="en-US" dirty="0"/>
           </a:p>
@@ -6986,7 +6986,7 @@
               <a:buNone/>
             </a:pPr>
             <a:r>
-              <a:rPr lang="en-US" sz="1400" b="1" dirty="0">
+              <a:rPr lang="en-US" sz="1300" b="1" dirty="0">
                 <a:solidFill>
                   <a:srgbClr val="FFFFFF"/>
                 </a:solidFill>
@@ -6996,7 +6996,7 @@
               </a:rPr>
               <a:t>A  Prepare; record time and address</a:t>
             </a:r>
-            <a:endParaRPr lang="en-US" sz="1400" dirty="0"/>
+            <a:endParaRPr lang="en-US" sz="1300" dirty="0"/>
           </a:p>
           <a:p>
             <a:pPr indent="0" marL="0">
@@ -7006,7 +7006,7 @@
               <a:buNone/>
             </a:pPr>
             <a:r>
-              <a:rPr lang="en-US" sz="1400" b="1" dirty="0">
+              <a:rPr lang="en-US" sz="1300" b="1" dirty="0">
                 <a:solidFill>
                   <a:srgbClr val="FFFFFF"/>
                 </a:solidFill>
@@ -7016,7 +7016,7 @@
               </a:rPr>
               <a:t>B  What has landed, and when</a:t>
             </a:r>
-            <a:endParaRPr lang="en-US" sz="1400" dirty="0"/>
+            <a:endParaRPr lang="en-US" sz="1300" dirty="0"/>
           </a:p>
           <a:p>
             <a:pPr indent="0" marL="0">
@@ -7026,7 +7026,7 @@
               <a:buNone/>
             </a:pPr>
             <a:r>
-              <a:rPr lang="en-US" sz="1400" b="1" dirty="0">
+              <a:rPr lang="en-US" sz="1300" b="1" dirty="0">
                 <a:solidFill>
                   <a:srgbClr val="FFFFFF"/>
                 </a:solidFill>
@@ -7036,7 +7036,7 @@
               </a:rPr>
               <a:t>C  Sync both logs; seal; record</a:t>
             </a:r>
-            <a:endParaRPr lang="en-US" sz="1400" dirty="0"/>
+            <a:endParaRPr lang="en-US" sz="1300" dirty="0"/>
           </a:p>
           <a:p>
             <a:pPr indent="0" marL="0">
@@ -7046,7 +7046,7 @@
               <a:buNone/>
             </a:pPr>
             <a:r>
-              <a:rPr lang="en-US" sz="1400" b="1" dirty="0">
+              <a:rPr lang="en-US" sz="1300" b="1" dirty="0">
                 <a:solidFill>
                   <a:srgbClr val="FFFFFF"/>
                 </a:solidFill>
@@ -7056,7 +7056,7 @@
               </a:rPr>
               <a:t>D  validate-logs, per Region</a:t>
             </a:r>
-            <a:endParaRPr lang="en-US" sz="1400" dirty="0"/>
+            <a:endParaRPr lang="en-US" sz="1300" dirty="0"/>
           </a:p>
           <a:p>
             <a:pPr indent="0" marL="0">
@@ -7066,7 +7066,7 @@
               <a:buNone/>
             </a:pPr>
             <a:r>
-              <a:rPr lang="en-US" sz="1400" b="1" dirty="0">
+              <a:rPr lang="en-US" sz="1300" b="1" dirty="0">
                 <a:solidFill>
                   <a:srgbClr val="FFFFFF"/>
                 </a:solidFill>
@@ -7076,7 +7076,7 @@
               </a:rPr>
               <a:t>E  Working copies</a:t>
             </a:r>
-            <a:endParaRPr lang="en-US" sz="1400" dirty="0"/>
+            <a:endParaRPr lang="en-US" sz="1300" dirty="0"/>
           </a:p>
           <a:p>
             <a:pPr indent="0" marL="0">
@@ -7086,7 +7086,7 @@
               <a:buNone/>
             </a:pPr>
             <a:r>
-              <a:rPr lang="en-US" sz="1400" b="1" dirty="0">
+              <a:rPr lang="en-US" sz="1300" b="1" dirty="0">
                 <a:solidFill>
                   <a:srgbClr val="FFFFFF"/>
                 </a:solidFill>
@@ -7096,7 +7096,7 @@
               </a:rPr>
               <a:t>F  History, then metadata, ETags</a:t>
             </a:r>
-            <a:endParaRPr lang="en-US" sz="1400" dirty="0"/>
+            <a:endParaRPr lang="en-US" sz="1300" dirty="0"/>
           </a:p>
           <a:p>
             <a:pPr indent="0" marL="0">
@@ -7106,7 +7106,7 @@
               <a:buNone/>
             </a:pPr>
             <a:r>
-              <a:rPr lang="en-US" sz="1400" b="1" dirty="0">
+              <a:rPr lang="en-US" sz="1300" b="1" dirty="0">
                 <a:solidFill>
                   <a:srgbClr val="FFFFFF"/>
                 </a:solidFill>
@@ -7116,7 +7116,7 @@
               </a:rPr>
               <a:t>G  Recover by version ID</a:t>
             </a:r>
-            <a:endParaRPr lang="en-US" sz="1400" dirty="0"/>
+            <a:endParaRPr lang="en-US" sz="1300" dirty="0"/>
           </a:p>
           <a:p>
             <a:pPr indent="0" marL="0">
@@ -7126,7 +7126,7 @@
               <a:buNone/>
             </a:pPr>
             <a:r>
-              <a:rPr lang="en-US" sz="1400" b="1" dirty="0">
+              <a:rPr lang="en-US" sz="1300" b="1" dirty="0">
                 <a:solidFill>
                   <a:srgbClr val="FFFFFF"/>
                 </a:solidFill>
@@ -7136,7 +7136,27 @@
               </a:rPr>
               <a:t>H  Prove nothing changed; close</a:t>
             </a:r>
-            <a:endParaRPr lang="en-US" sz="1400" dirty="0"/>
+            <a:endParaRPr lang="en-US" sz="1300" dirty="0"/>
+          </a:p>
+          <a:p>
+            <a:pPr indent="0" marL="0">
+              <a:spcAft>
+                <a:spcPts val="500"/>
+              </a:spcAft>
+              <a:buNone/>
+            </a:pPr>
+            <a:r>
+              <a:rPr lang="en-US" sz="1300" b="1" dirty="0">
+                <a:solidFill>
+                  <a:srgbClr val="FFFFFF"/>
+                </a:solidFill>
+                <a:latin typeface="Open Sans" pitchFamily="34" charset="0"/>
+                <a:ea typeface="Open Sans" pitchFamily="34" charset="-122"/>
+                <a:cs typeface="Open Sans" pitchFamily="34" charset="-120"/>
+              </a:rPr>
+              <a:t>I  Hours later: collect again, compare</a:t>
+            </a:r>
+            <a:endParaRPr lang="en-US" sz="1300" dirty="0"/>
           </a:p>
         </p:txBody>
       </p:sp>
@@ -7617,7 +7637,7 @@
                 <a:ea typeface="Open Sans" pitchFamily="34" charset="-122"/>
                 <a:cs typeface="Open Sans" pitchFamily="34" charset="-120"/>
               </a:rPr>
-              <a:t>Now: the end-of-day quiz, five short answers on Days 1 to 5. Next: Session 13 opens the logs.</a:t>
+              <a:t>Now: the end-of-day quiz on Days 1 to 5. Before Session 13: Part I, the second collection.</a:t>
             </a:r>
             <a:endParaRPr lang="en-US" sz="1300" dirty="0"/>
           </a:p>
@@ -9011,7 +9031,7 @@
                 <a:ea typeface="Open Sans" pitchFamily="34" charset="-122"/>
                 <a:cs typeface="Open Sans" pitchFamily="34" charset="-120"/>
               </a:rPr>
-              <a:t>Since Session 11 nobody has touched the case bucket. Every request recorded now is yours, made on purpose. Write down when and from where before you make the first one.</a:t>
+              <a:t>Since Session 11 nobody has touched the case bucket: every request recorded now is yours, so write down when and from where first. The incident is only about an hour old, so you collect twice: now, and again hours later.</a:t>
             </a:r>
             <a:endParaRPr lang="en-US" sz="1500" dirty="0"/>
           </a:p>

</xml_diff>